<commit_message>
chore(theme): reconfirm SGD palette and clear old hex samples
Dark tokens already match Pablo’s globals.css; light mode remains the
generator pass of #4015ca / #7254cb. Update presentation fixture,
DESIGN.md samples, and registry design-md artifacts so nothing still
quotes the pre-SGD violet ramp.

Co-authored-by: Pablo Orozco <pablopvsky@users.noreply.github.com>
</commit_message>
<xml_diff>
--- a/apps/www/public/fixtures/sample.pptx
+++ b/apps/www/public/fixtures/sample.pptx
@@ -1302,7 +1302,7 @@
     <p:bg>
       <p:bgPr>
         <a:solidFill>
-          <a:srgbClr val="121B48"/>
+          <a:srgbClr val="27005F"/>
         </a:solidFill>
       </p:bgPr>
     </p:bg>
@@ -1335,7 +1335,7 @@
             <a:avLst/>
           </a:prstGeom>
           <a:solidFill>
-            <a:srgbClr val="964CE1"/>
+            <a:srgbClr val="4015CA"/>
           </a:solidFill>
           <a:ln/>
         </p:spPr>
@@ -1367,7 +1367,7 @@
             <a:r>
               <a:rPr lang="en-US" sz="1200" spc="300" kern="0" dirty="0">
                 <a:solidFill>
-                  <a:srgbClr val="D7C0FA"/>
+                  <a:srgbClr val="C5CDFF"/>
                 </a:solidFill>
                 <a:latin typeface="Menlo" pitchFamily="34" charset="0"/>
                 <a:ea typeface="Menlo" pitchFamily="34" charset="-122"/>
@@ -1409,7 +1409,7 @@
             <a:r>
               <a:rPr lang="en-US" sz="5400" b="1" dirty="0">
                 <a:solidFill>
-                  <a:srgbClr val="F6F9FF"/>
+                  <a:srgbClr val="FCFAFF"/>
                 </a:solidFill>
                 <a:latin typeface="Inter" pitchFamily="34" charset="0"/>
                 <a:ea typeface="Inter" pitchFamily="34" charset="-122"/>
@@ -1429,7 +1429,7 @@
             <a:r>
               <a:rPr lang="en-US" sz="5400" b="1" dirty="0">
                 <a:solidFill>
-                  <a:srgbClr val="F6F9FF"/>
+                  <a:srgbClr val="FCFAFF"/>
                 </a:solidFill>
                 <a:latin typeface="Inter" pitchFamily="34" charset="0"/>
                 <a:ea typeface="Inter" pitchFamily="34" charset="-122"/>
@@ -1456,7 +1456,7 @@
             <a:avLst/>
           </a:prstGeom>
           <a:solidFill>
-            <a:srgbClr val="964CE1"/>
+            <a:srgbClr val="4015CA"/>
           </a:solidFill>
           <a:ln/>
         </p:spPr>
@@ -1491,7 +1491,7 @@
             <a:r>
               <a:rPr lang="en-US" sz="1600" dirty="0">
                 <a:solidFill>
-                  <a:srgbClr val="C2D4FF"/>
+                  <a:srgbClr val="D9D1FF"/>
                 </a:solidFill>
                 <a:latin typeface="Inter" pitchFamily="34" charset="0"/>
                 <a:ea typeface="Inter" pitchFamily="34" charset="-122"/>
@@ -1530,7 +1530,7 @@
             <a:r>
               <a:rPr lang="en-US" sz="1200" dirty="0">
                 <a:solidFill>
-                  <a:srgbClr val="D7C0FA"/>
+                  <a:srgbClr val="C5CDFF"/>
                 </a:solidFill>
                 <a:latin typeface="Menlo" pitchFamily="34" charset="0"/>
                 <a:ea typeface="Menlo" pitchFamily="34" charset="-122"/>
@@ -1556,7 +1556,7 @@
     <p:bg>
       <p:bgPr>
         <a:solidFill>
-          <a:srgbClr val="F6F9FF"/>
+          <a:srgbClr val="FCFAFF"/>
         </a:solidFill>
       </p:bgPr>
     </p:bg>
@@ -1589,7 +1589,7 @@
             <a:avLst/>
           </a:prstGeom>
           <a:solidFill>
-            <a:srgbClr val="964CE1"/>
+            <a:srgbClr val="4015CA"/>
           </a:solidFill>
           <a:ln/>
         </p:spPr>
@@ -1621,7 +1621,7 @@
             <a:r>
               <a:rPr lang="en-US" sz="1100" spc="200" kern="0" dirty="0">
                 <a:solidFill>
-                  <a:srgbClr val="7D35C2"/>
+                  <a:srgbClr val="5446E1"/>
                 </a:solidFill>
                 <a:latin typeface="Menlo" pitchFamily="34" charset="0"/>
                 <a:ea typeface="Menlo" pitchFamily="34" charset="-122"/>
@@ -1660,7 +1660,7 @@
             <a:r>
               <a:rPr lang="en-US" sz="3400" b="1" dirty="0">
                 <a:solidFill>
-                  <a:srgbClr val="121B48"/>
+                  <a:srgbClr val="27005F"/>
                 </a:solidFill>
                 <a:latin typeface="Inter" pitchFamily="34" charset="0"/>
                 <a:ea typeface="Inter" pitchFamily="34" charset="-122"/>
@@ -1687,11 +1687,11 @@
             <a:avLst/>
           </a:prstGeom>
           <a:solidFill>
-            <a:srgbClr val="FAF9FC"/>
+            <a:srgbClr val="FDFDFF"/>
           </a:solidFill>
           <a:ln w="6350">
             <a:solidFill>
-              <a:srgbClr val="C2D4FF"/>
+              <a:srgbClr val="D9D1FF"/>
             </a:solidFill>
             <a:prstDash val="solid"/>
           </a:ln>
@@ -1724,7 +1724,7 @@
             <a:r>
               <a:rPr lang="en-US" sz="1100" dirty="0">
                 <a:solidFill>
-                  <a:srgbClr val="4B5C9A"/>
+                  <a:srgbClr val="6949BF"/>
                 </a:solidFill>
                 <a:latin typeface="Menlo" pitchFamily="34" charset="0"/>
                 <a:ea typeface="Menlo" pitchFamily="34" charset="-122"/>
@@ -1751,11 +1751,11 @@
             <a:avLst/>
           </a:prstGeom>
           <a:solidFill>
-            <a:srgbClr val="F7F4FC"/>
+            <a:srgbClr val="F7F8FF"/>
           </a:solidFill>
           <a:ln w="6350">
             <a:solidFill>
-              <a:srgbClr val="C2D4FF"/>
+              <a:srgbClr val="D9D1FF"/>
             </a:solidFill>
             <a:prstDash val="solid"/>
           </a:ln>
@@ -1788,7 +1788,7 @@
             <a:r>
               <a:rPr lang="en-US" sz="1100" dirty="0">
                 <a:solidFill>
-                  <a:srgbClr val="4B5C9A"/>
+                  <a:srgbClr val="6949BF"/>
                 </a:solidFill>
                 <a:latin typeface="Menlo" pitchFamily="34" charset="0"/>
                 <a:ea typeface="Menlo" pitchFamily="34" charset="-122"/>
@@ -1815,11 +1815,11 @@
             <a:avLst/>
           </a:prstGeom>
           <a:solidFill>
-            <a:srgbClr val="F1EAFE"/>
+            <a:srgbClr val="EEF1FF"/>
           </a:solidFill>
           <a:ln w="6350">
             <a:solidFill>
-              <a:srgbClr val="C2D4FF"/>
+              <a:srgbClr val="D9D1FF"/>
             </a:solidFill>
             <a:prstDash val="solid"/>
           </a:ln>
@@ -1852,7 +1852,7 @@
             <a:r>
               <a:rPr lang="en-US" sz="1100" dirty="0">
                 <a:solidFill>
-                  <a:srgbClr val="4B5C9A"/>
+                  <a:srgbClr val="6949BF"/>
                 </a:solidFill>
                 <a:latin typeface="Menlo" pitchFamily="34" charset="0"/>
                 <a:ea typeface="Menlo" pitchFamily="34" charset="-122"/>
@@ -1879,11 +1879,11 @@
             <a:avLst/>
           </a:prstGeom>
           <a:solidFill>
-            <a:srgbClr val="EBDEFF"/>
+            <a:srgbClr val="E2E7FF"/>
           </a:solidFill>
           <a:ln w="6350">
             <a:solidFill>
-              <a:srgbClr val="C2D4FF"/>
+              <a:srgbClr val="D9D1FF"/>
             </a:solidFill>
             <a:prstDash val="solid"/>
           </a:ln>
@@ -1916,7 +1916,7 @@
             <a:r>
               <a:rPr lang="en-US" sz="1100" dirty="0">
                 <a:solidFill>
-                  <a:srgbClr val="4B5C9A"/>
+                  <a:srgbClr val="6949BF"/>
                 </a:solidFill>
                 <a:latin typeface="Menlo" pitchFamily="34" charset="0"/>
                 <a:ea typeface="Menlo" pitchFamily="34" charset="-122"/>
@@ -1943,11 +1943,11 @@
             <a:avLst/>
           </a:prstGeom>
           <a:solidFill>
-            <a:srgbClr val="E2D1FE"/>
+            <a:srgbClr val="D5DCFF"/>
           </a:solidFill>
           <a:ln w="6350">
             <a:solidFill>
-              <a:srgbClr val="C2D4FF"/>
+              <a:srgbClr val="D9D1FF"/>
             </a:solidFill>
             <a:prstDash val="solid"/>
           </a:ln>
@@ -1980,7 +1980,7 @@
             <a:r>
               <a:rPr lang="en-US" sz="1100" dirty="0">
                 <a:solidFill>
-                  <a:srgbClr val="4B5C9A"/>
+                  <a:srgbClr val="6949BF"/>
                 </a:solidFill>
                 <a:latin typeface="Menlo" pitchFamily="34" charset="0"/>
                 <a:ea typeface="Menlo" pitchFamily="34" charset="-122"/>
@@ -2007,11 +2007,11 @@
             <a:avLst/>
           </a:prstGeom>
           <a:solidFill>
-            <a:srgbClr val="D7C0FA"/>
+            <a:srgbClr val="C5CDFF"/>
           </a:solidFill>
           <a:ln w="6350">
             <a:solidFill>
-              <a:srgbClr val="C2D4FF"/>
+              <a:srgbClr val="D9D1FF"/>
             </a:solidFill>
             <a:prstDash val="solid"/>
           </a:ln>
@@ -2044,7 +2044,7 @@
             <a:r>
               <a:rPr lang="en-US" sz="1100" dirty="0">
                 <a:solidFill>
-                  <a:srgbClr val="4B5C9A"/>
+                  <a:srgbClr val="6949BF"/>
                 </a:solidFill>
                 <a:latin typeface="Menlo" pitchFamily="34" charset="0"/>
                 <a:ea typeface="Menlo" pitchFamily="34" charset="-122"/>
@@ -2071,11 +2071,11 @@
             <a:avLst/>
           </a:prstGeom>
           <a:solidFill>
-            <a:srgbClr val="C9A9F5"/>
+            <a:srgbClr val="B0B9FF"/>
           </a:solidFill>
           <a:ln w="6350">
             <a:solidFill>
-              <a:srgbClr val="C2D4FF"/>
+              <a:srgbClr val="D9D1FF"/>
             </a:solidFill>
             <a:prstDash val="solid"/>
           </a:ln>
@@ -2108,7 +2108,7 @@
             <a:r>
               <a:rPr lang="en-US" sz="1100" dirty="0">
                 <a:solidFill>
-                  <a:srgbClr val="4B5C9A"/>
+                  <a:srgbClr val="6949BF"/>
                 </a:solidFill>
                 <a:latin typeface="Menlo" pitchFamily="34" charset="0"/>
                 <a:ea typeface="Menlo" pitchFamily="34" charset="-122"/>
@@ -2135,11 +2135,11 @@
             <a:avLst/>
           </a:prstGeom>
           <a:solidFill>
-            <a:srgbClr val="B78CEF"/>
+            <a:srgbClr val="939BFF"/>
           </a:solidFill>
           <a:ln w="6350">
             <a:solidFill>
-              <a:srgbClr val="C2D4FF"/>
+              <a:srgbClr val="D9D1FF"/>
             </a:solidFill>
             <a:prstDash val="solid"/>
           </a:ln>
@@ -2172,7 +2172,7 @@
             <a:r>
               <a:rPr lang="en-US" sz="1100" dirty="0">
                 <a:solidFill>
-                  <a:srgbClr val="4B5C9A"/>
+                  <a:srgbClr val="6949BF"/>
                 </a:solidFill>
                 <a:latin typeface="Menlo" pitchFamily="34" charset="0"/>
                 <a:ea typeface="Menlo" pitchFamily="34" charset="-122"/>
@@ -2199,11 +2199,11 @@
             <a:avLst/>
           </a:prstGeom>
           <a:solidFill>
-            <a:srgbClr val="964CE1"/>
+            <a:srgbClr val="4015CA"/>
           </a:solidFill>
           <a:ln w="6350">
             <a:solidFill>
-              <a:srgbClr val="C2D4FF"/>
+              <a:srgbClr val="D9D1FF"/>
             </a:solidFill>
             <a:prstDash val="solid"/>
           </a:ln>
@@ -2236,7 +2236,7 @@
             <a:r>
               <a:rPr lang="en-US" sz="1100" dirty="0">
                 <a:solidFill>
-                  <a:srgbClr val="4B5C9A"/>
+                  <a:srgbClr val="6949BF"/>
                 </a:solidFill>
                 <a:latin typeface="Menlo" pitchFamily="34" charset="0"/>
                 <a:ea typeface="Menlo" pitchFamily="34" charset="-122"/>
@@ -2263,11 +2263,11 @@
             <a:avLst/>
           </a:prstGeom>
           <a:solidFill>
-            <a:srgbClr val="8841CE"/>
+            <a:srgbClr val="3500B6"/>
           </a:solidFill>
           <a:ln w="6350">
             <a:solidFill>
-              <a:srgbClr val="C2D4FF"/>
+              <a:srgbClr val="D9D1FF"/>
             </a:solidFill>
             <a:prstDash val="solid"/>
           </a:ln>
@@ -2300,7 +2300,7 @@
             <a:r>
               <a:rPr lang="en-US" sz="1100" dirty="0">
                 <a:solidFill>
-                  <a:srgbClr val="4B5C9A"/>
+                  <a:srgbClr val="6949BF"/>
                 </a:solidFill>
                 <a:latin typeface="Menlo" pitchFamily="34" charset="0"/>
                 <a:ea typeface="Menlo" pitchFamily="34" charset="-122"/>
@@ -2327,11 +2327,11 @@
             <a:avLst/>
           </a:prstGeom>
           <a:solidFill>
-            <a:srgbClr val="7D35C2"/>
+            <a:srgbClr val="5446E1"/>
           </a:solidFill>
           <a:ln w="6350">
             <a:solidFill>
-              <a:srgbClr val="C2D4FF"/>
+              <a:srgbClr val="D9D1FF"/>
             </a:solidFill>
             <a:prstDash val="solid"/>
           </a:ln>
@@ -2364,7 +2364,7 @@
             <a:r>
               <a:rPr lang="en-US" sz="1100" dirty="0">
                 <a:solidFill>
-                  <a:srgbClr val="4B5C9A"/>
+                  <a:srgbClr val="6949BF"/>
                 </a:solidFill>
                 <a:latin typeface="Menlo" pitchFamily="34" charset="0"/>
                 <a:ea typeface="Menlo" pitchFamily="34" charset="-122"/>
@@ -2391,11 +2391,11 @@
             <a:avLst/>
           </a:prstGeom>
           <a:solidFill>
-            <a:srgbClr val="421A68"/>
+            <a:srgbClr val="272370"/>
           </a:solidFill>
           <a:ln w="6350">
             <a:solidFill>
-              <a:srgbClr val="C2D4FF"/>
+              <a:srgbClr val="D9D1FF"/>
             </a:solidFill>
             <a:prstDash val="solid"/>
           </a:ln>
@@ -2428,7 +2428,7 @@
             <a:r>
               <a:rPr lang="en-US" sz="1100" dirty="0">
                 <a:solidFill>
-                  <a:srgbClr val="4B5C9A"/>
+                  <a:srgbClr val="6949BF"/>
                 </a:solidFill>
                 <a:latin typeface="Menlo" pitchFamily="34" charset="0"/>
                 <a:ea typeface="Menlo" pitchFamily="34" charset="-122"/>
@@ -2467,7 +2467,7 @@
             <a:r>
               <a:rPr lang="en-US" sz="1300" b="1" dirty="0">
                 <a:solidFill>
-                  <a:srgbClr val="7D35C2"/>
+                  <a:srgbClr val="5446E1"/>
                 </a:solidFill>
                 <a:latin typeface="Menlo" pitchFamily="34" charset="0"/>
                 <a:ea typeface="Menlo" pitchFamily="34" charset="-122"/>
@@ -2506,7 +2506,7 @@
             <a:r>
               <a:rPr lang="en-US" sz="1400" dirty="0">
                 <a:solidFill>
-                  <a:srgbClr val="4B5C9A"/>
+                  <a:srgbClr val="6949BF"/>
                 </a:solidFill>
                 <a:latin typeface="Inter" pitchFamily="34" charset="0"/>
                 <a:ea typeface="Inter" pitchFamily="34" charset="-122"/>
@@ -2545,7 +2545,7 @@
             <a:r>
               <a:rPr lang="en-US" sz="1300" b="1" dirty="0">
                 <a:solidFill>
-                  <a:srgbClr val="7D35C2"/>
+                  <a:srgbClr val="5446E1"/>
                 </a:solidFill>
                 <a:latin typeface="Menlo" pitchFamily="34" charset="0"/>
                 <a:ea typeface="Menlo" pitchFamily="34" charset="-122"/>
@@ -2584,7 +2584,7 @@
             <a:r>
               <a:rPr lang="en-US" sz="1400" dirty="0">
                 <a:solidFill>
-                  <a:srgbClr val="4B5C9A"/>
+                  <a:srgbClr val="6949BF"/>
                 </a:solidFill>
                 <a:latin typeface="Inter" pitchFamily="34" charset="0"/>
                 <a:ea typeface="Inter" pitchFamily="34" charset="-122"/>
@@ -2623,7 +2623,7 @@
             <a:r>
               <a:rPr lang="en-US" sz="1300" b="1" dirty="0">
                 <a:solidFill>
-                  <a:srgbClr val="7D35C2"/>
+                  <a:srgbClr val="5446E1"/>
                 </a:solidFill>
                 <a:latin typeface="Menlo" pitchFamily="34" charset="0"/>
                 <a:ea typeface="Menlo" pitchFamily="34" charset="-122"/>
@@ -2662,7 +2662,7 @@
             <a:r>
               <a:rPr lang="en-US" sz="1400" dirty="0">
                 <a:solidFill>
-                  <a:srgbClr val="4B5C9A"/>
+                  <a:srgbClr val="6949BF"/>
                 </a:solidFill>
                 <a:latin typeface="Inter" pitchFamily="34" charset="0"/>
                 <a:ea typeface="Inter" pitchFamily="34" charset="-122"/>
@@ -2701,7 +2701,7 @@
             <a:r>
               <a:rPr lang="en-US" sz="1300" b="1" dirty="0">
                 <a:solidFill>
-                  <a:srgbClr val="7D35C2"/>
+                  <a:srgbClr val="5446E1"/>
                 </a:solidFill>
                 <a:latin typeface="Menlo" pitchFamily="34" charset="0"/>
                 <a:ea typeface="Menlo" pitchFamily="34" charset="-122"/>
@@ -2740,7 +2740,7 @@
             <a:r>
               <a:rPr lang="en-US" sz="1400" dirty="0">
                 <a:solidFill>
-                  <a:srgbClr val="4B5C9A"/>
+                  <a:srgbClr val="6949BF"/>
                 </a:solidFill>
                 <a:latin typeface="Inter" pitchFamily="34" charset="0"/>
                 <a:ea typeface="Inter" pitchFamily="34" charset="-122"/>
@@ -2779,7 +2779,7 @@
             <a:r>
               <a:rPr lang="en-US" sz="1300" b="1" dirty="0">
                 <a:solidFill>
-                  <a:srgbClr val="7D35C2"/>
+                  <a:srgbClr val="5446E1"/>
                 </a:solidFill>
                 <a:latin typeface="Menlo" pitchFamily="34" charset="0"/>
                 <a:ea typeface="Menlo" pitchFamily="34" charset="-122"/>
@@ -2818,7 +2818,7 @@
             <a:r>
               <a:rPr lang="en-US" sz="1400" dirty="0">
                 <a:solidFill>
-                  <a:srgbClr val="4B5C9A"/>
+                  <a:srgbClr val="6949BF"/>
                 </a:solidFill>
                 <a:latin typeface="Inter" pitchFamily="34" charset="0"/>
                 <a:ea typeface="Inter" pitchFamily="34" charset="-122"/>
@@ -2844,7 +2844,7 @@
     <p:bg>
       <p:bgPr>
         <a:solidFill>
-          <a:srgbClr val="F6F9FF"/>
+          <a:srgbClr val="FCFAFF"/>
         </a:solidFill>
       </p:bgPr>
     </p:bg>
@@ -2877,7 +2877,7 @@
             <a:avLst/>
           </a:prstGeom>
           <a:solidFill>
-            <a:srgbClr val="964CE1"/>
+            <a:srgbClr val="4015CA"/>
           </a:solidFill>
           <a:ln/>
         </p:spPr>
@@ -2909,7 +2909,7 @@
             <a:r>
               <a:rPr lang="en-US" sz="1100" spc="200" kern="0" dirty="0">
                 <a:solidFill>
-                  <a:srgbClr val="7D35C2"/>
+                  <a:srgbClr val="5446E1"/>
                 </a:solidFill>
                 <a:latin typeface="Menlo" pitchFamily="34" charset="0"/>
                 <a:ea typeface="Menlo" pitchFamily="34" charset="-122"/>
@@ -2948,7 +2948,7 @@
             <a:r>
               <a:rPr lang="en-US" sz="3400" b="1" dirty="0">
                 <a:solidFill>
-                  <a:srgbClr val="121B48"/>
+                  <a:srgbClr val="27005F"/>
                 </a:solidFill>
                 <a:latin typeface="Inter" pitchFamily="34" charset="0"/>
                 <a:ea typeface="Inter" pitchFamily="34" charset="-122"/>
@@ -2987,7 +2987,7 @@
             <a:r>
               <a:rPr lang="en-US" sz="1300" dirty="0">
                 <a:solidFill>
-                  <a:srgbClr val="7D35C2"/>
+                  <a:srgbClr val="5446E1"/>
                 </a:solidFill>
                 <a:latin typeface="Menlo" pitchFamily="34" charset="0"/>
                 <a:ea typeface="Menlo" pitchFamily="34" charset="-122"/>
@@ -3026,7 +3026,7 @@
             <a:r>
               <a:rPr lang="en-US" sz="1200" dirty="0">
                 <a:solidFill>
-                  <a:srgbClr val="6D84D5"/>
+                  <a:srgbClr val="936CFF"/>
                 </a:solidFill>
                 <a:latin typeface="Menlo" pitchFamily="34" charset="0"/>
                 <a:ea typeface="Menlo" pitchFamily="34" charset="-122"/>
@@ -3065,7 +3065,7 @@
             <a:r>
               <a:rPr lang="en-US" sz="4000" b="1" dirty="0">
                 <a:solidFill>
-                  <a:srgbClr val="121B48"/>
+                  <a:srgbClr val="27005F"/>
                 </a:solidFill>
                 <a:latin typeface="Inter" pitchFamily="34" charset="0"/>
                 <a:ea typeface="Inter" pitchFamily="34" charset="-122"/>
@@ -3104,7 +3104,7 @@
             <a:r>
               <a:rPr lang="en-US" sz="1200" dirty="0">
                 <a:solidFill>
-                  <a:srgbClr val="6D84D5"/>
+                  <a:srgbClr val="936CFF"/>
                 </a:solidFill>
                 <a:latin typeface="Menlo" pitchFamily="34" charset="0"/>
                 <a:ea typeface="Menlo" pitchFamily="34" charset="-122"/>
@@ -3143,7 +3143,7 @@
             <a:r>
               <a:rPr lang="en-US" sz="3200" b="1" dirty="0">
                 <a:solidFill>
-                  <a:srgbClr val="121B48"/>
+                  <a:srgbClr val="27005F"/>
                 </a:solidFill>
                 <a:latin typeface="Inter" pitchFamily="34" charset="0"/>
                 <a:ea typeface="Inter" pitchFamily="34" charset="-122"/>
@@ -3182,7 +3182,7 @@
             <a:r>
               <a:rPr lang="en-US" sz="1200" dirty="0">
                 <a:solidFill>
-                  <a:srgbClr val="6D84D5"/>
+                  <a:srgbClr val="936CFF"/>
                 </a:solidFill>
                 <a:latin typeface="Menlo" pitchFamily="34" charset="0"/>
                 <a:ea typeface="Menlo" pitchFamily="34" charset="-122"/>
@@ -3221,7 +3221,7 @@
             <a:r>
               <a:rPr lang="en-US" sz="2700" b="1" dirty="0">
                 <a:solidFill>
-                  <a:srgbClr val="121B48"/>
+                  <a:srgbClr val="27005F"/>
                 </a:solidFill>
                 <a:latin typeface="Inter" pitchFamily="34" charset="0"/>
                 <a:ea typeface="Inter" pitchFamily="34" charset="-122"/>
@@ -3260,7 +3260,7 @@
             <a:r>
               <a:rPr lang="en-US" sz="1200" dirty="0">
                 <a:solidFill>
-                  <a:srgbClr val="6D84D5"/>
+                  <a:srgbClr val="936CFF"/>
                 </a:solidFill>
                 <a:latin typeface="Menlo" pitchFamily="34" charset="0"/>
                 <a:ea typeface="Menlo" pitchFamily="34" charset="-122"/>
@@ -3299,7 +3299,7 @@
             <a:r>
               <a:rPr lang="en-US" sz="1600" dirty="0">
                 <a:solidFill>
-                  <a:srgbClr val="4B5C9A"/>
+                  <a:srgbClr val="6949BF"/>
                 </a:solidFill>
                 <a:latin typeface="Inter" pitchFamily="34" charset="0"/>
                 <a:ea typeface="Inter" pitchFamily="34" charset="-122"/>
@@ -3325,7 +3325,7 @@
     <p:bg>
       <p:bgPr>
         <a:solidFill>
-          <a:srgbClr val="F6F9FF"/>
+          <a:srgbClr val="FCFAFF"/>
         </a:solidFill>
       </p:bgPr>
     </p:bg>
@@ -3358,7 +3358,7 @@
             <a:avLst/>
           </a:prstGeom>
           <a:solidFill>
-            <a:srgbClr val="964CE1"/>
+            <a:srgbClr val="4015CA"/>
           </a:solidFill>
           <a:ln/>
         </p:spPr>
@@ -3390,7 +3390,7 @@
             <a:r>
               <a:rPr lang="en-US" sz="1100" spc="200" kern="0" dirty="0">
                 <a:solidFill>
-                  <a:srgbClr val="7D35C2"/>
+                  <a:srgbClr val="5446E1"/>
                 </a:solidFill>
                 <a:latin typeface="Menlo" pitchFamily="34" charset="0"/>
                 <a:ea typeface="Menlo" pitchFamily="34" charset="-122"/>
@@ -3429,7 +3429,7 @@
             <a:r>
               <a:rPr lang="en-US" sz="3400" b="1" dirty="0">
                 <a:solidFill>
-                  <a:srgbClr val="121B48"/>
+                  <a:srgbClr val="27005F"/>
                 </a:solidFill>
                 <a:latin typeface="Inter" pitchFamily="34" charset="0"/>
                 <a:ea typeface="Inter" pitchFamily="34" charset="-122"/>
@@ -3468,7 +3468,7 @@
             <a:r>
               <a:rPr lang="en-US" sz="1500" dirty="0">
                 <a:solidFill>
-                  <a:srgbClr val="4B5C9A"/>
+                  <a:srgbClr val="6949BF"/>
                 </a:solidFill>
                 <a:latin typeface="Inter" pitchFamily="34" charset="0"/>
                 <a:ea typeface="Inter" pitchFamily="34" charset="-122"/>
@@ -3507,7 +3507,7 @@
             <a:r>
               <a:rPr lang="en-US" sz="1300" dirty="0">
                 <a:solidFill>
-                  <a:srgbClr val="7D35C2"/>
+                  <a:srgbClr val="5446E1"/>
                 </a:solidFill>
                 <a:latin typeface="Menlo" pitchFamily="34" charset="0"/>
                 <a:ea typeface="Menlo" pitchFamily="34" charset="-122"/>
@@ -3534,7 +3534,7 @@
             <a:avLst/>
           </a:prstGeom>
           <a:solidFill>
-            <a:srgbClr val="964CE1"/>
+            <a:srgbClr val="4015CA"/>
           </a:solidFill>
           <a:ln/>
         </p:spPr>
@@ -3566,7 +3566,7 @@
             <a:r>
               <a:rPr lang="en-US" sz="1200" dirty="0">
                 <a:solidFill>
-                  <a:srgbClr val="4B5C9A"/>
+                  <a:srgbClr val="6949BF"/>
                 </a:solidFill>
                 <a:latin typeface="Menlo" pitchFamily="34" charset="0"/>
                 <a:ea typeface="Menlo" pitchFamily="34" charset="-122"/>
@@ -3605,7 +3605,7 @@
             <a:r>
               <a:rPr lang="en-US" sz="1300" dirty="0">
                 <a:solidFill>
-                  <a:srgbClr val="7D35C2"/>
+                  <a:srgbClr val="5446E1"/>
                 </a:solidFill>
                 <a:latin typeface="Menlo" pitchFamily="34" charset="0"/>
                 <a:ea typeface="Menlo" pitchFamily="34" charset="-122"/>
@@ -3632,7 +3632,7 @@
             <a:avLst/>
           </a:prstGeom>
           <a:solidFill>
-            <a:srgbClr val="D7C0FA"/>
+            <a:srgbClr val="C5CDFF"/>
           </a:solidFill>
           <a:ln/>
         </p:spPr>
@@ -3664,7 +3664,7 @@
             <a:r>
               <a:rPr lang="en-US" sz="1200" dirty="0">
                 <a:solidFill>
-                  <a:srgbClr val="4B5C9A"/>
+                  <a:srgbClr val="6949BF"/>
                 </a:solidFill>
                 <a:latin typeface="Menlo" pitchFamily="34" charset="0"/>
                 <a:ea typeface="Menlo" pitchFamily="34" charset="-122"/>
@@ -3703,7 +3703,7 @@
             <a:r>
               <a:rPr lang="en-US" sz="1300" dirty="0">
                 <a:solidFill>
-                  <a:srgbClr val="7D35C2"/>
+                  <a:srgbClr val="5446E1"/>
                 </a:solidFill>
                 <a:latin typeface="Menlo" pitchFamily="34" charset="0"/>
                 <a:ea typeface="Menlo" pitchFamily="34" charset="-122"/>
@@ -3730,7 +3730,7 @@
             <a:avLst/>
           </a:prstGeom>
           <a:solidFill>
-            <a:srgbClr val="964CE1"/>
+            <a:srgbClr val="4015CA"/>
           </a:solidFill>
           <a:ln/>
         </p:spPr>
@@ -3762,7 +3762,7 @@
             <a:r>
               <a:rPr lang="en-US" sz="1200" dirty="0">
                 <a:solidFill>
-                  <a:srgbClr val="4B5C9A"/>
+                  <a:srgbClr val="6949BF"/>
                 </a:solidFill>
                 <a:latin typeface="Menlo" pitchFamily="34" charset="0"/>
                 <a:ea typeface="Menlo" pitchFamily="34" charset="-122"/>
@@ -3801,7 +3801,7 @@
             <a:r>
               <a:rPr lang="en-US" sz="1300" dirty="0">
                 <a:solidFill>
-                  <a:srgbClr val="7D35C2"/>
+                  <a:srgbClr val="5446E1"/>
                 </a:solidFill>
                 <a:latin typeface="Menlo" pitchFamily="34" charset="0"/>
                 <a:ea typeface="Menlo" pitchFamily="34" charset="-122"/>
@@ -3828,7 +3828,7 @@
             <a:avLst/>
           </a:prstGeom>
           <a:solidFill>
-            <a:srgbClr val="D7C0FA"/>
+            <a:srgbClr val="C5CDFF"/>
           </a:solidFill>
           <a:ln/>
         </p:spPr>
@@ -3860,7 +3860,7 @@
             <a:r>
               <a:rPr lang="en-US" sz="1200" dirty="0">
                 <a:solidFill>
-                  <a:srgbClr val="4B5C9A"/>
+                  <a:srgbClr val="6949BF"/>
                 </a:solidFill>
                 <a:latin typeface="Menlo" pitchFamily="34" charset="0"/>
                 <a:ea typeface="Menlo" pitchFamily="34" charset="-122"/>
@@ -3886,7 +3886,7 @@
     <p:bg>
       <p:bgPr>
         <a:solidFill>
-          <a:srgbClr val="F6F9FF"/>
+          <a:srgbClr val="FCFAFF"/>
         </a:solidFill>
       </p:bgPr>
     </p:bg>
@@ -3919,7 +3919,7 @@
             <a:avLst/>
           </a:prstGeom>
           <a:solidFill>
-            <a:srgbClr val="964CE1"/>
+            <a:srgbClr val="4015CA"/>
           </a:solidFill>
           <a:ln/>
         </p:spPr>
@@ -3951,7 +3951,7 @@
             <a:r>
               <a:rPr lang="en-US" sz="1100" spc="200" kern="0" dirty="0">
                 <a:solidFill>
-                  <a:srgbClr val="7D35C2"/>
+                  <a:srgbClr val="5446E1"/>
                 </a:solidFill>
                 <a:latin typeface="Menlo" pitchFamily="34" charset="0"/>
                 <a:ea typeface="Menlo" pitchFamily="34" charset="-122"/>
@@ -3990,7 +3990,7 @@
             <a:r>
               <a:rPr lang="en-US" sz="3400" b="1" dirty="0">
                 <a:solidFill>
-                  <a:srgbClr val="121B48"/>
+                  <a:srgbClr val="27005F"/>
                 </a:solidFill>
                 <a:latin typeface="Inter" pitchFamily="34" charset="0"/>
                 <a:ea typeface="Inter" pitchFamily="34" charset="-122"/>
@@ -4019,11 +4019,11 @@
             </a:avLst>
           </a:prstGeom>
           <a:solidFill>
-            <a:srgbClr val="F6F9FF"/>
+            <a:srgbClr val="FCFAFF"/>
           </a:solidFill>
           <a:ln w="12700">
             <a:solidFill>
-              <a:srgbClr val="C2D4FF"/>
+              <a:srgbClr val="D9D1FF"/>
             </a:solidFill>
             <a:prstDash val="solid"/>
           </a:ln>
@@ -4056,7 +4056,7 @@
             <a:r>
               <a:rPr lang="en-US" sz="1200" dirty="0">
                 <a:solidFill>
-                  <a:srgbClr val="121B48"/>
+                  <a:srgbClr val="27005F"/>
                 </a:solidFill>
                 <a:latin typeface="Menlo" pitchFamily="34" charset="0"/>
                 <a:ea typeface="Menlo" pitchFamily="34" charset="-122"/>
@@ -4095,7 +4095,7 @@
             <a:r>
               <a:rPr lang="en-US" sz="1700" b="1" dirty="0">
                 <a:solidFill>
-                  <a:srgbClr val="121B48"/>
+                  <a:srgbClr val="27005F"/>
                 </a:solidFill>
                 <a:latin typeface="Inter" pitchFamily="34" charset="0"/>
                 <a:ea typeface="Inter" pitchFamily="34" charset="-122"/>
@@ -4124,11 +4124,11 @@
             </a:avLst>
           </a:prstGeom>
           <a:solidFill>
-            <a:srgbClr val="F0F6FF"/>
+            <a:srgbClr val="F9F6FF"/>
           </a:solidFill>
           <a:ln w="12700">
             <a:solidFill>
-              <a:srgbClr val="C2D4FF"/>
+              <a:srgbClr val="D9D1FF"/>
             </a:solidFill>
             <a:prstDash val="solid"/>
           </a:ln>
@@ -4161,7 +4161,7 @@
             <a:r>
               <a:rPr lang="en-US" sz="1200" dirty="0">
                 <a:solidFill>
-                  <a:srgbClr val="121B48"/>
+                  <a:srgbClr val="27005F"/>
                 </a:solidFill>
                 <a:latin typeface="Menlo" pitchFamily="34" charset="0"/>
                 <a:ea typeface="Menlo" pitchFamily="34" charset="-122"/>
@@ -4200,7 +4200,7 @@
             <a:r>
               <a:rPr lang="en-US" sz="1700" b="1" dirty="0">
                 <a:solidFill>
-                  <a:srgbClr val="121B48"/>
+                  <a:srgbClr val="27005F"/>
                 </a:solidFill>
                 <a:latin typeface="Inter" pitchFamily="34" charset="0"/>
                 <a:ea typeface="Inter" pitchFamily="34" charset="-122"/>
@@ -4229,11 +4229,11 @@
             </a:avLst>
           </a:prstGeom>
           <a:solidFill>
-            <a:srgbClr val="E3ECFF"/>
+            <a:srgbClr val="F0ECFF"/>
           </a:solidFill>
           <a:ln w="12700">
             <a:solidFill>
-              <a:srgbClr val="C2D4FF"/>
+              <a:srgbClr val="D9D1FF"/>
             </a:solidFill>
             <a:prstDash val="solid"/>
           </a:ln>
@@ -4266,7 +4266,7 @@
             <a:r>
               <a:rPr lang="en-US" sz="1200" dirty="0">
                 <a:solidFill>
-                  <a:srgbClr val="121B48"/>
+                  <a:srgbClr val="27005F"/>
                 </a:solidFill>
                 <a:latin typeface="Menlo" pitchFamily="34" charset="0"/>
                 <a:ea typeface="Menlo" pitchFamily="34" charset="-122"/>
@@ -4305,7 +4305,7 @@
             <a:r>
               <a:rPr lang="en-US" sz="1700" b="1" dirty="0">
                 <a:solidFill>
-                  <a:srgbClr val="121B48"/>
+                  <a:srgbClr val="27005F"/>
                 </a:solidFill>
                 <a:latin typeface="Inter" pitchFamily="34" charset="0"/>
                 <a:ea typeface="Inter" pitchFamily="34" charset="-122"/>
@@ -4334,11 +4334,11 @@
             </a:avLst>
           </a:prstGeom>
           <a:solidFill>
-            <a:srgbClr val="964CE1"/>
+            <a:srgbClr val="4015CA"/>
           </a:solidFill>
           <a:ln w="12700">
             <a:solidFill>
-              <a:srgbClr val="C2D4FF"/>
+              <a:srgbClr val="D9D1FF"/>
             </a:solidFill>
             <a:prstDash val="solid"/>
           </a:ln>
@@ -4449,7 +4449,7 @@
             <a:r>
               <a:rPr lang="en-US" sz="1500" dirty="0">
                 <a:solidFill>
-                  <a:srgbClr val="4B5C9A"/>
+                  <a:srgbClr val="6949BF"/>
                 </a:solidFill>
                 <a:latin typeface="Inter" pitchFamily="34" charset="0"/>
                 <a:ea typeface="Inter" pitchFamily="34" charset="-122"/>
@@ -4475,7 +4475,7 @@
     <p:bg>
       <p:bgPr>
         <a:solidFill>
-          <a:srgbClr val="421A68"/>
+          <a:srgbClr val="272370"/>
         </a:solidFill>
       </p:bgPr>
     </p:bg>
@@ -4508,7 +4508,7 @@
             <a:avLst/>
           </a:prstGeom>
           <a:solidFill>
-            <a:srgbClr val="964CE1"/>
+            <a:srgbClr val="4015CA"/>
           </a:solidFill>
           <a:ln/>
         </p:spPr>
@@ -4602,7 +4602,7 @@
             <a:r>
               <a:rPr lang="en-US" sz="1400" dirty="0">
                 <a:solidFill>
-                  <a:srgbClr val="D7C0FA"/>
+                  <a:srgbClr val="C5CDFF"/>
                 </a:solidFill>
                 <a:latin typeface="Menlo" pitchFamily="34" charset="0"/>
                 <a:ea typeface="Menlo" pitchFamily="34" charset="-122"/>

</xml_diff>